<commit_message>
chore(fase-2): atualiza apresentacao executiva pptx e relatorio executivo pdf com hiperlinks ativos
</commit_message>
<xml_diff>
--- a/Tech Challenge Fase 2/Apresentacao_Executiva_TechChallenge_2.pptx
+++ b/Tech Challenge Fase 2/Apresentacao_Executiva_TechChallenge_2.pptx
@@ -684,7 +684,7 @@
                 <a:tab pos="0" algn="l"/>
               </a:tabLst>
             </a:pPr>
-            <a:fld id="{DD83E141-D211-4F19-A1BC-F2261B7BEB00}" type="slidenum">
+            <a:fld id="{83C63911-8A3C-4025-A367-DCDA4C1E5B09}" type="slidenum">
               <a:rPr lang="en-US" sz="1200" b="0" u="none" strike="noStrike">
                 <a:solidFill>
                   <a:srgbClr val="888888"/>
@@ -1770,7 +1770,7 @@
                 <a:tab pos="0" algn="l"/>
               </a:tabLst>
             </a:pPr>
-            <a:fld id="{0FA8D92E-560B-4E4B-851C-EA703DD6B09F}" type="slidenum">
+            <a:fld id="{82557937-36C1-49E8-95F4-29D1ADCDC750}" type="slidenum">
               <a:rPr lang="en-US" sz="1200" b="0" u="none" strike="noStrike">
                 <a:solidFill>
                   <a:srgbClr val="888888"/>
@@ -2521,7 +2521,7 @@
                 <a:tab pos="0" algn="l"/>
               </a:tabLst>
             </a:pPr>
-            <a:fld id="{4C5BE013-E9A6-4912-A9B3-C1079C49C93F}" type="slidenum">
+            <a:fld id="{885C53E5-28EF-478E-9A3B-C7519F06E397}" type="slidenum">
               <a:rPr lang="en-US" sz="1200" b="0" u="none" strike="noStrike">
                 <a:solidFill>
                   <a:srgbClr val="888888"/>
@@ -2765,7 +2765,7 @@
                 <a:tab pos="0" algn="l"/>
               </a:tabLst>
             </a:pPr>
-            <a:fld id="{5CE98AA4-0685-4BF1-A915-705EAF59E04E}" type="slidenum">
+            <a:fld id="{8EACF42D-7166-4792-9138-AC55FEB4386F}" type="slidenum">
               <a:rPr lang="en-US" sz="1200" b="0" u="none" strike="noStrike">
                 <a:solidFill>
                   <a:srgbClr val="888888"/>
@@ -3917,7 +3917,7 @@
                 <a:tab pos="0" algn="l"/>
               </a:tabLst>
             </a:pPr>
-            <a:fld id="{1C651CB9-0477-42B7-BAFA-A04EA6F33B09}" type="slidenum">
+            <a:fld id="{DB948119-01E7-4470-9368-8A1A22D458F8}" type="slidenum">
               <a:rPr lang="en-US" sz="1200" b="0" u="none" strike="noStrike">
                 <a:solidFill>
                   <a:srgbClr val="888888"/>
@@ -4615,7 +4615,7 @@
                 <a:tab pos="0" algn="l"/>
               </a:tabLst>
             </a:pPr>
-            <a:fld id="{F99FFC0F-EAE4-41F1-95A7-AA2F8B7EABB1}" type="slidenum">
+            <a:fld id="{F00B677F-4D2E-47A2-B7A2-D3CB5A447CBC}" type="slidenum">
               <a:rPr lang="en-US" sz="1200" b="0" u="none" strike="noStrike">
                 <a:solidFill>
                   <a:srgbClr val="888888"/>
@@ -4925,7 +4925,7 @@
                 <a:tab pos="0" algn="l"/>
               </a:tabLst>
             </a:pPr>
-            <a:fld id="{CD5C1B33-14E6-42F1-9BAC-6136FCB16248}" type="slidenum">
+            <a:fld id="{F25BE5BF-9627-4CA6-A31F-83CB9FDE740D}" type="slidenum">
               <a:rPr lang="en-US" sz="1200" b="0" u="none" strike="noStrike">
                 <a:solidFill>
                   <a:srgbClr val="888888"/>
@@ -5623,7 +5623,7 @@
                 <a:tab pos="0" algn="l"/>
               </a:tabLst>
             </a:pPr>
-            <a:fld id="{81207ABA-FCD2-4A86-BEE9-0D479B4CACF4}" type="slidenum">
+            <a:fld id="{75F1A5E7-B1D7-40AD-9CEE-F4BEA9EF7BE0}" type="slidenum">
               <a:rPr lang="en-US" sz="1200" b="0" u="none" strike="noStrike">
                 <a:solidFill>
                   <a:srgbClr val="888888"/>
@@ -6321,7 +6321,7 @@
                 <a:tab pos="0" algn="l"/>
               </a:tabLst>
             </a:pPr>
-            <a:fld id="{5FC9E64F-62D2-4A00-AA9F-2746FB04DC7A}" type="slidenum">
+            <a:fld id="{F134F9E0-29BE-43E2-87BF-80CD60AB0EB4}" type="slidenum">
               <a:rPr lang="en-US" sz="1200" b="0" u="none" strike="noStrike">
                 <a:solidFill>
                   <a:srgbClr val="888888"/>
@@ -7407,7 +7407,7 @@
                 <a:tab pos="0" algn="l"/>
               </a:tabLst>
             </a:pPr>
-            <a:fld id="{A4C9DDD7-BD74-4EF5-A596-133E0076D326}" type="slidenum">
+            <a:fld id="{80B63E44-E4D2-4E7B-B0C2-6FFE9E9E31F8}" type="slidenum">
               <a:rPr lang="en-US" sz="1200" b="0" u="none" strike="noStrike">
                 <a:solidFill>
                   <a:srgbClr val="888888"/>
@@ -9269,7 +9269,7 @@
                 <a:tab pos="0" algn="l"/>
               </a:tabLst>
             </a:pPr>
-            <a:fld id="{321B931F-D32C-465D-802E-CC0CF8099CC1}" type="slidenum">
+            <a:fld id="{1113BA29-E3F8-4032-9F6A-B1A05FECF3CB}" type="slidenum">
               <a:rPr lang="en-US" sz="1200" b="0" u="none" strike="noStrike">
                 <a:solidFill>
                   <a:srgbClr val="888888"/>
@@ -9967,7 +9967,7 @@
                 <a:tab pos="0" algn="l"/>
               </a:tabLst>
             </a:pPr>
-            <a:fld id="{F9B2AD66-1A93-49D7-8E49-F4B8C9A8DBA5}" type="slidenum">
+            <a:fld id="{A7CF48A5-D8C9-41BC-AABA-A34CF4A4C8EB}" type="slidenum">
               <a:rPr lang="en-US" sz="1200" b="0" u="none" strike="noStrike">
                 <a:solidFill>
                   <a:srgbClr val="888888"/>
@@ -10277,7 +10277,7 @@
                 <a:tab pos="0" algn="l"/>
               </a:tabLst>
             </a:pPr>
-            <a:fld id="{26A38A0C-147B-4342-8949-63571C7A5CC1}" type="slidenum">
+            <a:fld id="{FE6B0505-811A-4E8E-8AB5-BFB2154A54BA}" type="slidenum">
               <a:rPr lang="en-US" sz="1200" b="0" u="none" strike="noStrike">
                 <a:solidFill>
                   <a:srgbClr val="888888"/>
@@ -11363,7 +11363,7 @@
                 <a:tab pos="0" algn="l"/>
               </a:tabLst>
             </a:pPr>
-            <a:fld id="{5747D990-1886-486F-9FDF-5145FA2C8B3F}" type="slidenum">
+            <a:fld id="{22A40D61-EAAC-4490-B714-9A90E8C7129B}" type="slidenum">
               <a:rPr lang="en-US" sz="1200" b="0" u="none" strike="noStrike">
                 <a:solidFill>
                   <a:srgbClr val="888888"/>
@@ -12114,7 +12114,7 @@
                 <a:tab pos="0" algn="l"/>
               </a:tabLst>
             </a:pPr>
-            <a:fld id="{E1383D24-35DC-48C4-A510-73308EC752A6}" type="slidenum">
+            <a:fld id="{38C86643-6736-47E7-9D70-AF8C6152C3D8}" type="slidenum">
               <a:rPr lang="en-US" sz="1200" b="0" u="none" strike="noStrike">
                 <a:solidFill>
                   <a:srgbClr val="888888"/>
@@ -12812,7 +12812,7 @@
                 <a:tab pos="0" algn="l"/>
               </a:tabLst>
             </a:pPr>
-            <a:fld id="{A1C9EBC5-28ED-46AF-A3C4-84A53611EB29}" type="slidenum">
+            <a:fld id="{6EB5C8FB-8A10-444E-8FA2-CDCE66F5787A}" type="slidenum">
               <a:rPr lang="en-US" sz="1200" b="0" u="none" strike="noStrike">
                 <a:solidFill>
                   <a:srgbClr val="888888"/>
@@ -13122,7 +13122,7 @@
                 <a:tab pos="0" algn="l"/>
               </a:tabLst>
             </a:pPr>
-            <a:fld id="{6DBCC990-974B-490B-89CF-6E439888F454}" type="slidenum">
+            <a:fld id="{2C368EB7-E0C2-4DAE-8D6B-50281EEEBC4F}" type="slidenum">
               <a:rPr lang="en-US" sz="1200" b="0" u="none" strike="noStrike">
                 <a:solidFill>
                   <a:srgbClr val="888888"/>
@@ -13820,7 +13820,7 @@
                 <a:tab pos="0" algn="l"/>
               </a:tabLst>
             </a:pPr>
-            <a:fld id="{6D1DB437-6EC5-4F7F-A0C4-F70F9605A74B}" type="slidenum">
+            <a:fld id="{C669DAD9-BDBE-4127-B9DF-C8FD6D15A5BA}" type="slidenum">
               <a:rPr lang="en-US" sz="1200" b="0" u="none" strike="noStrike">
                 <a:solidFill>
                   <a:srgbClr val="888888"/>
@@ -14906,7 +14906,7 @@
                 <a:tab pos="0" algn="l"/>
               </a:tabLst>
             </a:pPr>
-            <a:fld id="{240226CA-EDC0-41DB-8ABB-FBCD90621C44}" type="slidenum">
+            <a:fld id="{0AC771BB-6D4E-4435-9333-FED32463838E}" type="slidenum">
               <a:rPr lang="en-US" sz="1200" b="0" u="none" strike="noStrike">
                 <a:solidFill>
                   <a:srgbClr val="888888"/>
@@ -16768,7 +16768,7 @@
                 <a:tab pos="0" algn="l"/>
               </a:tabLst>
             </a:pPr>
-            <a:fld id="{F47536AA-C535-46BF-A039-A64017242DC0}" type="slidenum">
+            <a:fld id="{2CDD2C0D-3D0D-4F78-8BEF-4AF11A5CC857}" type="slidenum">
               <a:rPr lang="en-US" sz="1200" b="0" u="none" strike="noStrike">
                 <a:solidFill>
                   <a:srgbClr val="888888"/>
@@ -17078,7 +17078,7 @@
                 <a:tab pos="0" algn="l"/>
               </a:tabLst>
             </a:pPr>
-            <a:fld id="{23206CAD-3D1D-4C6C-A4EA-297983DBCC2A}" type="slidenum">
+            <a:fld id="{1498747C-3F35-4183-87F4-809B0A8B64F5}" type="slidenum">
               <a:rPr lang="en-US" sz="1200" b="0" u="none" strike="noStrike">
                 <a:solidFill>
                   <a:srgbClr val="888888"/>
@@ -17322,7 +17322,7 @@
                 <a:tab pos="0" algn="l"/>
               </a:tabLst>
             </a:pPr>
-            <a:fld id="{E17A01B4-0D26-4BC7-A548-89D06A3E7074}" type="slidenum">
+            <a:fld id="{12E3373A-CDB5-4E23-BF57-B3AEA3C46160}" type="slidenum">
               <a:rPr lang="en-US" sz="1200" b="0" u="none" strike="noStrike">
                 <a:solidFill>
                   <a:srgbClr val="888888"/>
@@ -17477,14 +17477,14 @@
           <a:fontRef idx="minor"/>
         </p:style>
         <p:txBody>
-          <a:bodyPr wrap="none" lIns="0" tIns="0" rIns="0" bIns="0" anchor="t">
-            <a:spAutoFit/>
+          <a:bodyPr anchor="ctr">
+            <a:noAutofit/>
           </a:bodyPr>
           <a:p>
             <a:pPr/>
-            <a:endParaRPr lang="pt-BR" sz="1350" b="0" u="none" strike="noStrike">
-              <a:solidFill>
-                <a:srgbClr val="38BDF8"/>
+            <a:endParaRPr lang="pt-BR" sz="1400" b="0" u="none" strike="noStrike">
+              <a:solidFill>
+                <a:srgbClr val="FFFFFF"/>
               </a:solidFill>
               <a:effectLst/>
               <a:uFillTx/>
@@ -17563,7 +17563,7 @@
         <p:spPr>
           <a:xfrm>
             <a:off x="1028880" y="3222000"/>
-            <a:ext cx="7086240" cy="502920"/>
+            <a:ext cx="7086240" cy="646200"/>
           </a:xfrm>
           <a:prstGeom prst="rect">
             <a:avLst/>
@@ -17584,10 +17584,18 @@
             <a:spAutoFit/>
           </a:bodyPr>
           <a:p>
+            <a:pPr>
+              <a:lnSpc>
+                <a:spcPct val="100000"/>
+              </a:lnSpc>
+              <a:tabLst>
+                <a:tab pos="0" algn="l"/>
+              </a:tabLst>
+            </a:pPr>
             <a:r>
               <a:rPr lang="pt-BR" sz="1350" b="0" u="none" strike="noStrike">
                 <a:solidFill>
-                  <a:srgbClr val="94A3B8"/>
+                  <a:srgbClr val="38BDF8"/>
                 </a:solidFill>
                 <a:effectLst/>
                 <a:uFillTx/>
@@ -17598,7 +17606,7 @@
             </a:r>
             <a:endParaRPr lang="pt-BR" sz="1350" b="0" u="none" strike="noStrike">
               <a:solidFill>
-                <a:srgbClr val="94A3B8"/>
+                <a:srgbClr val="000000"/>
               </a:solidFill>
               <a:effectLst/>
               <a:uFillTx/>
@@ -17615,7 +17623,7 @@
         </p:nvSpPr>
         <p:spPr>
           <a:xfrm>
-            <a:off x="1714680" y="4482000"/>
+            <a:off x="1714680" y="4590000"/>
             <a:ext cx="5714640" cy="731160"/>
           </a:xfrm>
           <a:prstGeom prst="roundRect">
@@ -17651,7 +17659,7 @@
             <a:noAutofit/>
           </a:bodyPr>
           <a:p>
-            <a:pPr algn="ctr">
+            <a:pPr>
               <a:lnSpc>
                 <a:spcPct val="100000"/>
               </a:lnSpc>
@@ -17660,18 +17668,18 @@
               </a:tabLst>
             </a:pPr>
             <a:r>
-              <a:rPr lang="en-US" sz="1400" b="0" u="none" strike="noStrike">
-                <a:solidFill>
-                  <a:srgbClr val="00D2FF"/>
-                </a:solidFill>
-                <a:effectLst/>
-                <a:uFillTx/>
-                <a:latin typeface="Calibri"/>
-                <a:ea typeface="Calibri"/>
-              </a:rPr>
-              <a:t>🏢 Consultoria de IA Agêntica   |   📅 Setembro 2026   |   🎯 Caso Olist</a:t>
-            </a:r>
-            <a:endParaRPr lang="pt-BR" sz="1400" b="0" u="none" strike="noStrike">
+              <a:rPr lang="pt-BR" sz="1100" b="0" u="none" strike="noStrike">
+                <a:solidFill>
+                  <a:srgbClr val="FBBF24"/>
+                </a:solidFill>
+                <a:effectLst/>
+                <a:uFillTx/>
+                <a:latin typeface="Arial"/>
+                <a:ea typeface="Arial"/>
+              </a:rPr>
+              <a:t>Consultoria de IA Agêntica  |  Setembro 2026  |  Caso Olist</a:t>
+            </a:r>
+            <a:endParaRPr lang="pt-BR" sz="1100" b="0" u="none" strike="noStrike">
               <a:solidFill>
                 <a:srgbClr val="FFFFFF"/>
               </a:solidFill>
@@ -17707,7 +17715,7 @@
         </p:spPr>
         <p:txBody>
           <a:bodyPr lIns="91440" tIns="45720" rIns="91440" bIns="45720" anchor="t">
-            <a:normAutofit fontScale="25000" lnSpcReduction="19999"/>
+            <a:normAutofit/>
           </a:bodyPr>
           <a:p>
             <a:pPr indent="0" algn="l">
@@ -17720,9 +17728,9 @@
               </a:tabLst>
             </a:pPr>
             <a:r>
-              <a:rPr lang="en-US" sz="7680" b="0" u="none" strike="noStrike">
-                <a:solidFill>
-                  <a:srgbClr val="C8C8C8"/>
+              <a:rPr lang="pt-BR" sz="1400" b="0" u="none" strike="noStrike">
+                <a:solidFill>
+                  <a:srgbClr val="94A3B8"/>
                 </a:solidFill>
                 <a:effectLst/>
                 <a:uFillTx/>
@@ -17731,7 +17739,7 @@
               </a:rPr>
               <a:t>Tech Challenge – Fase 2</a:t>
             </a:r>
-            <a:endParaRPr lang="pt-BR" sz="7680" b="0" u="none" strike="noStrike">
+            <a:endParaRPr lang="pt-BR" sz="1400" b="0" u="none" strike="noStrike">
               <a:solidFill>
                 <a:srgbClr val="000000"/>
               </a:solidFill>
@@ -17829,18 +17837,18 @@
               </a:tabLst>
             </a:pPr>
             <a:r>
-              <a:rPr lang="en-US" sz="3200" b="0" u="none" strike="noStrike">
-                <a:solidFill>
-                  <a:srgbClr val="A3284D"/>
-                </a:solidFill>
-                <a:effectLst/>
-                <a:uFillTx/>
-                <a:latin typeface="Calibri"/>
-                <a:ea typeface="Calibri"/>
+              <a:rPr lang="pt-BR" sz="1800" b="1" u="none" strike="noStrike">
+                <a:solidFill>
+                  <a:srgbClr val="FFFFFF"/>
+                </a:solidFill>
+                <a:effectLst/>
+                <a:uFillTx/>
+                <a:latin typeface="Arial"/>
+                <a:ea typeface="Arial"/>
               </a:rPr>
               <a:t>Agentes de IA</a:t>
             </a:r>
-            <a:endParaRPr lang="pt-BR" sz="3200" b="0" u="none" strike="noStrike">
+            <a:endParaRPr lang="pt-BR" sz="1800" b="0" u="none" strike="noStrike">
               <a:solidFill>
                 <a:srgbClr val="000000"/>
               </a:solidFill>
@@ -17881,7 +17889,7 @@
             <a:noAutofit/>
           </a:bodyPr>
           <a:p>
-            <a:pPr>
+            <a:pPr algn="ctr">
               <a:lnSpc>
                 <a:spcPct val="100000"/>
               </a:lnSpc>
@@ -17890,78 +17898,18 @@
               </a:tabLst>
             </a:pPr>
             <a:r>
-              <a:rPr lang="en-US" sz="1200" b="0" u="none" strike="noStrike">
-                <a:solidFill>
-                  <a:srgbClr val="A3284D"/>
-                </a:solidFill>
-                <a:effectLst/>
-                <a:uFillTx/>
-                <a:latin typeface="Calibri"/>
-                <a:ea typeface="Calibri"/>
-              </a:rPr>
-              <a:t>Alessandro Dos Santos - RM376092</a:t>
-            </a:r>
-            <a:endParaRPr lang="pt-BR" sz="1200" b="0" u="none" strike="noStrike">
-              <a:solidFill>
-                <a:srgbClr val="000000"/>
-              </a:solidFill>
-              <a:effectLst/>
-              <a:uFillTx/>
-              <a:latin typeface="Arial"/>
-            </a:endParaRPr>
-          </a:p>
-          <a:p>
-            <a:pPr>
-              <a:lnSpc>
-                <a:spcPct val="100000"/>
-              </a:lnSpc>
-              <a:tabLst>
-                <a:tab pos="0" algn="l"/>
-              </a:tabLst>
-            </a:pPr>
-            <a:r>
-              <a:rPr lang="en-US" sz="1200" b="0" u="none" strike="noStrike">
-                <a:solidFill>
-                  <a:srgbClr val="A3284D"/>
-                </a:solidFill>
-                <a:effectLst/>
-                <a:uFillTx/>
-                <a:latin typeface="Calibri"/>
-                <a:ea typeface="Calibri"/>
-              </a:rPr>
-              <a:t>André Palermo - RM374038</a:t>
-            </a:r>
-            <a:endParaRPr lang="pt-BR" sz="1200" b="0" u="none" strike="noStrike">
-              <a:solidFill>
-                <a:srgbClr val="000000"/>
-              </a:solidFill>
-              <a:effectLst/>
-              <a:uFillTx/>
-              <a:latin typeface="Arial"/>
-            </a:endParaRPr>
-          </a:p>
-          <a:p>
-            <a:pPr>
-              <a:lnSpc>
-                <a:spcPct val="100000"/>
-              </a:lnSpc>
-              <a:tabLst>
-                <a:tab pos="0" algn="l"/>
-              </a:tabLst>
-            </a:pPr>
-            <a:r>
-              <a:rPr lang="en-US" sz="1200" b="0" u="none" strike="noStrike">
-                <a:solidFill>
-                  <a:srgbClr val="A3284D"/>
-                </a:solidFill>
-                <a:effectLst/>
-                <a:uFillTx/>
-                <a:latin typeface="Calibri"/>
-                <a:ea typeface="Calibri"/>
-              </a:rPr>
-              <a:t>Michel Lages Balbuena - RM375667</a:t>
-            </a:r>
-            <a:endParaRPr lang="pt-BR" sz="1200" b="0" u="none" strike="noStrike">
+              <a:rPr lang="pt-BR" sz="1050" b="0" u="none" strike="noStrike">
+                <a:solidFill>
+                  <a:srgbClr val="F1F5F9"/>
+                </a:solidFill>
+                <a:effectLst/>
+                <a:uFillTx/>
+                <a:latin typeface="Arial"/>
+                <a:ea typeface="Arial"/>
+              </a:rPr>
+              <a:t>Alessandro Dos Santos (RM376092)  |  André Palermo (RM374038)  |  Michel Lages Balbuena (RM375667)</a:t>
+            </a:r>
+            <a:endParaRPr lang="pt-BR" sz="1050" b="0" u="none" strike="noStrike">
               <a:solidFill>
                 <a:srgbClr val="000000"/>
               </a:solidFill>
@@ -18010,7 +17958,7 @@
         </p:nvSpPr>
         <p:spPr>
           <a:xfrm>
-            <a:off x="-4680" y="0"/>
+            <a:off x="0" y="0"/>
             <a:ext cx="9208800" cy="6857640"/>
           </a:xfrm>
           <a:prstGeom prst="rect">
@@ -18061,8 +18009,8 @@
         </p:nvSpPr>
         <p:spPr>
           <a:xfrm>
-            <a:off x="500040" y="1310760"/>
-            <a:ext cx="7948800" cy="366120"/>
+            <a:off x="502920" y="951120"/>
+            <a:ext cx="7945920" cy="365400"/>
           </a:xfrm>
           <a:prstGeom prst="rect">
             <a:avLst/>
@@ -18312,7 +18260,7 @@
         </p:spPr>
         <p:txBody>
           <a:bodyPr lIns="91440" tIns="45720" rIns="91440" bIns="45720" anchor="t">
-            <a:normAutofit fontScale="25000" lnSpcReduction="19999"/>
+            <a:normAutofit/>
           </a:bodyPr>
           <a:p>
             <a:pPr indent="0" algn="l">
@@ -18325,9 +18273,9 @@
               </a:tabLst>
             </a:pPr>
             <a:r>
-              <a:rPr lang="en-US" sz="7680" b="0" u="none" strike="noStrike">
-                <a:solidFill>
-                  <a:srgbClr val="C8C8C8"/>
+              <a:rPr lang="pt-BR" sz="1400" b="0" u="none" strike="noStrike">
+                <a:solidFill>
+                  <a:srgbClr val="94A3B8"/>
                 </a:solidFill>
                 <a:effectLst/>
                 <a:uFillTx/>
@@ -18336,7 +18284,7 @@
               </a:rPr>
               <a:t>Tech Challenge – Fase 2</a:t>
             </a:r>
-            <a:endParaRPr lang="pt-BR" sz="7680" b="0" u="none" strike="noStrike">
+            <a:endParaRPr lang="pt-BR" sz="1400" b="0" u="none" strike="noStrike">
               <a:solidFill>
                 <a:srgbClr val="000000"/>
               </a:solidFill>
@@ -18434,18 +18382,18 @@
               </a:tabLst>
             </a:pPr>
             <a:r>
-              <a:rPr lang="en-US" sz="3200" b="0" u="none" strike="noStrike">
-                <a:solidFill>
-                  <a:srgbClr val="A3284D"/>
-                </a:solidFill>
-                <a:effectLst/>
-                <a:uFillTx/>
-                <a:latin typeface="Calibri"/>
-                <a:ea typeface="Calibri"/>
+              <a:rPr lang="pt-BR" sz="1800" b="1" u="none" strike="noStrike">
+                <a:solidFill>
+                  <a:srgbClr val="FFFFFF"/>
+                </a:solidFill>
+                <a:effectLst/>
+                <a:uFillTx/>
+                <a:latin typeface="Arial"/>
+                <a:ea typeface="Arial"/>
               </a:rPr>
               <a:t>Agentes de IA</a:t>
             </a:r>
-            <a:endParaRPr lang="pt-BR" sz="3200" b="0" u="none" strike="noStrike">
+            <a:endParaRPr lang="pt-BR" sz="1800" b="0" u="none" strike="noStrike">
               <a:solidFill>
                 <a:srgbClr val="000000"/>
               </a:solidFill>
@@ -18468,8 +18416,8 @@
         </p:blipFill>
         <p:spPr>
           <a:xfrm>
-            <a:off x="548640" y="1800000"/>
-            <a:ext cx="4491360" cy="4188960"/>
+            <a:off x="548640" y="1783080"/>
+            <a:ext cx="4160160" cy="3840120"/>
           </a:xfrm>
           <a:prstGeom prst="rect">
             <a:avLst/>
@@ -18482,14 +18430,121 @@
       </p:pic>
       <p:sp>
         <p:nvSpPr>
-          <p:cNvPr id="137" name="Rounded Rectangle 190"/>
+          <p:cNvPr id="137" name="Rounded Rectangle 190">
+            <a:hlinkClick r:id="rId4"/>
+          </p:cNvPr>
           <p:cNvSpPr/>
           <p:nvPr/>
         </p:nvSpPr>
         <p:spPr>
           <a:xfrm>
-            <a:off x="5314320" y="1800000"/>
-            <a:ext cx="3253680" cy="4068720"/>
+            <a:off x="548640" y="5669280"/>
+            <a:ext cx="4160160" cy="383760"/>
+          </a:xfrm>
+          <a:prstGeom prst="roundRect">
+            <a:avLst>
+              <a:gd name="adj" fmla="val 16667"/>
+            </a:avLst>
+          </a:prstGeom>
+          <a:solidFill>
+            <a:srgbClr val="141B2D"/>
+          </a:solidFill>
+          <a:ln>
+            <a:solidFill>
+              <a:srgbClr val="334155"/>
+            </a:solidFill>
+            <a:round/>
+          </a:ln>
+          <a:effectLst>
+            <a:outerShdw blurRad="39960" dir="5400000" dist="23040" rotWithShape="0">
+              <a:srgbClr val="000000">
+                <a:alpha val="35000"/>
+              </a:srgbClr>
+            </a:outerShdw>
+          </a:effectLst>
+        </p:spPr>
+        <p:style>
+          <a:lnRef idx="1">
+            <a:schemeClr val="accent1"/>
+          </a:lnRef>
+          <a:fillRef idx="3">
+            <a:schemeClr val="accent1"/>
+          </a:fillRef>
+          <a:effectRef idx="2">
+            <a:schemeClr val="accent1"/>
+          </a:effectRef>
+          <a:fontRef idx="minor"/>
+        </p:style>
+        <p:txBody>
+          <a:bodyPr lIns="73080" tIns="36720" rIns="73080" bIns="36720" anchor="ctr">
+            <a:noAutofit/>
+          </a:bodyPr>
+          <a:p>
+            <a:pPr>
+              <a:lnSpc>
+                <a:spcPct val="100000"/>
+              </a:lnSpc>
+            </a:pPr>
+            <a:r>
+              <a:rPr lang="pt-BR" sz="750" b="1" u="none" strike="noStrike">
+                <a:solidFill>
+                  <a:srgbClr val="EA1D5D"/>
+                </a:solidFill>
+                <a:effectLst/>
+                <a:uFillTx/>
+                <a:latin typeface="Arial"/>
+                <a:ea typeface="Arial"/>
+              </a:rPr>
+              <a:t>🔗 Repositório GitHub (master) — matriz_impacto_viabilidade_risco.png</a:t>
+            </a:r>
+            <a:endParaRPr lang="pt-BR" sz="750" b="0" u="none" strike="noStrike">
+              <a:solidFill>
+                <a:srgbClr val="FFFFFF"/>
+              </a:solidFill>
+              <a:effectLst/>
+              <a:uFillTx/>
+              <a:latin typeface="Arial"/>
+            </a:endParaRPr>
+          </a:p>
+          <a:p>
+            <a:pPr>
+              <a:lnSpc>
+                <a:spcPct val="100000"/>
+              </a:lnSpc>
+            </a:pPr>
+            <a:r>
+              <a:rPr lang="pt-BR" sz="620" b="0" u="sng" strike="noStrike">
+                <a:solidFill>
+                  <a:srgbClr val="EA1D5D"/>
+                </a:solidFill>
+                <a:effectLst/>
+                <a:uFillTx/>
+                <a:latin typeface="Arial"/>
+                <a:ea typeface="Arial"/>
+              </a:rPr>
+              <a:t>https://github.com/professoralessandro/FIAP-POS-TECH-AGENTESIA/blob/master/Tech%20Challenge%20Fase%202/assets/matriz_impacto_viabilidade_risco.png</a:t>
+            </a:r>
+            <a:endParaRPr lang="pt-BR" sz="620" b="0" u="none" strike="noStrike">
+              <a:solidFill>
+                <a:srgbClr val="FFFFFF"/>
+              </a:solidFill>
+              <a:effectLst/>
+              <a:uFillTx/>
+              <a:latin typeface="Arial"/>
+            </a:endParaRPr>
+          </a:p>
+        </p:txBody>
+      </p:sp>
+      <p:sp>
+        <p:nvSpPr>
+          <p:cNvPr id="138" name="Rounded Rectangle 191"/>
+          <p:cNvSpPr/>
+          <p:nvPr/>
+        </p:nvSpPr>
+        <p:spPr>
+          <a:xfrm>
+            <a:off x="4846320" y="1783080"/>
+            <a:ext cx="3748680" cy="4269960"/>
           </a:xfrm>
           <a:prstGeom prst="roundRect">
             <a:avLst>
@@ -18830,7 +18885,7 @@
       </p:grpSpPr>
       <p:sp>
         <p:nvSpPr>
-          <p:cNvPr id="138" name="Google Shape;194;p27"/>
+          <p:cNvPr id="139" name="Google Shape;194;p27"/>
           <p:cNvSpPr/>
           <p:nvPr/>
         </p:nvSpPr>
@@ -18881,14 +18936,14 @@
       </p:sp>
       <p:sp>
         <p:nvSpPr>
-          <p:cNvPr id="139" name="Google Shape;195;p27"/>
+          <p:cNvPr id="140" name="Google Shape;195;p27"/>
           <p:cNvSpPr/>
           <p:nvPr/>
         </p:nvSpPr>
         <p:spPr>
           <a:xfrm>
-            <a:off x="548640" y="1205280"/>
-            <a:ext cx="7371360" cy="396720"/>
+            <a:off x="548640" y="841320"/>
+            <a:ext cx="7552440" cy="392760"/>
           </a:xfrm>
           <a:prstGeom prst="rect">
             <a:avLst/>
@@ -18942,7 +18997,7 @@
       </p:sp>
       <p:sp>
         <p:nvSpPr>
-          <p:cNvPr id="140" name="Google Shape;202;p27"/>
+          <p:cNvPr id="141" name="Google Shape;202;p27"/>
           <p:cNvSpPr/>
           <p:nvPr/>
         </p:nvSpPr>
@@ -18993,7 +19048,7 @@
       </p:sp>
       <p:sp>
         <p:nvSpPr>
-          <p:cNvPr id="141" name="Google Shape;203;p27"/>
+          <p:cNvPr id="142" name="Google Shape;203;p27"/>
           <p:cNvSpPr/>
           <p:nvPr/>
         </p:nvSpPr>
@@ -19054,7 +19109,7 @@
       </p:sp>
       <p:sp>
         <p:nvSpPr>
-          <p:cNvPr id="142" name="Google Shape;204;p27"/>
+          <p:cNvPr id="143" name="Google Shape;204;p27"/>
           <p:cNvSpPr/>
           <p:nvPr/>
         </p:nvSpPr>
@@ -19115,7 +19170,7 @@
       </p:sp>
       <p:sp>
         <p:nvSpPr>
-          <p:cNvPr id="143" name="PlaceHolder 1"/>
+          <p:cNvPr id="144" name="PlaceHolder 1"/>
           <p:cNvSpPr>
             <a:spLocks noGrp="1"/>
           </p:cNvSpPr>
@@ -19138,7 +19193,7 @@
         </p:spPr>
         <p:txBody>
           <a:bodyPr lIns="91440" tIns="45720" rIns="91440" bIns="45720" anchor="t">
-            <a:normAutofit fontScale="25000" lnSpcReduction="19999"/>
+            <a:normAutofit/>
           </a:bodyPr>
           <a:p>
             <a:pPr indent="0" algn="l">
@@ -19151,9 +19206,9 @@
               </a:tabLst>
             </a:pPr>
             <a:r>
-              <a:rPr lang="en-US" sz="7680" b="0" u="none" strike="noStrike">
-                <a:solidFill>
-                  <a:srgbClr val="C8C8C8"/>
+              <a:rPr lang="pt-BR" sz="1400" b="0" u="none" strike="noStrike">
+                <a:solidFill>
+                  <a:srgbClr val="94A3B8"/>
                 </a:solidFill>
                 <a:effectLst/>
                 <a:uFillTx/>
@@ -19162,7 +19217,7 @@
               </a:rPr>
               <a:t>Tech Challenge – Fase 2</a:t>
             </a:r>
-            <a:endParaRPr lang="pt-BR" sz="7680" b="0" u="none" strike="noStrike">
+            <a:endParaRPr lang="pt-BR" sz="1400" b="0" u="none" strike="noStrike">
               <a:solidFill>
                 <a:srgbClr val="000000"/>
               </a:solidFill>
@@ -19175,7 +19230,7 @@
       </p:sp>
       <p:pic>
         <p:nvPicPr>
-          <p:cNvPr id="144" name="Google Shape;206;p27"/>
+          <p:cNvPr id="145" name="Google Shape;206;p27"/>
           <p:cNvPicPr/>
           <p:nvPr/>
         </p:nvPicPr>
@@ -19199,7 +19254,7 @@
       </p:pic>
       <p:pic>
         <p:nvPicPr>
-          <p:cNvPr id="145" name="Google Shape;207;p27"/>
+          <p:cNvPr id="146" name="Google Shape;207;p27"/>
           <p:cNvPicPr/>
           <p:nvPr/>
         </p:nvPicPr>
@@ -19223,7 +19278,7 @@
       </p:pic>
       <p:sp>
         <p:nvSpPr>
-          <p:cNvPr id="146" name="Google Shape;208;p27"/>
+          <p:cNvPr id="147" name="Google Shape;208;p27"/>
           <p:cNvSpPr/>
           <p:nvPr/>
         </p:nvSpPr>
@@ -19260,18 +19315,18 @@
               </a:tabLst>
             </a:pPr>
             <a:r>
-              <a:rPr lang="en-US" sz="3200" b="0" u="none" strike="noStrike">
-                <a:solidFill>
-                  <a:srgbClr val="A3284D"/>
-                </a:solidFill>
-                <a:effectLst/>
-                <a:uFillTx/>
-                <a:latin typeface="Calibri"/>
-                <a:ea typeface="Calibri"/>
+              <a:rPr lang="pt-BR" sz="1800" b="1" u="none" strike="noStrike">
+                <a:solidFill>
+                  <a:srgbClr val="FFFFFF"/>
+                </a:solidFill>
+                <a:effectLst/>
+                <a:uFillTx/>
+                <a:latin typeface="Arial"/>
+                <a:ea typeface="Arial"/>
               </a:rPr>
               <a:t>Agentes de IA</a:t>
             </a:r>
-            <a:endParaRPr lang="pt-BR" sz="3200" b="0" u="none" strike="noStrike">
+            <a:endParaRPr lang="pt-BR" sz="1800" b="0" u="none" strike="noStrike">
               <a:solidFill>
                 <a:srgbClr val="000000"/>
               </a:solidFill>
@@ -19284,7 +19339,7 @@
       </p:sp>
       <p:sp>
         <p:nvSpPr>
-          <p:cNvPr id="147" name="Rounded Rectangle 208"/>
+          <p:cNvPr id="148" name="Rounded Rectangle 208"/>
           <p:cNvSpPr/>
           <p:nvPr/>
         </p:nvSpPr>
@@ -19491,7 +19546,7 @@
       </p:sp>
       <p:sp>
         <p:nvSpPr>
-          <p:cNvPr id="148" name="Rounded Rectangle 209"/>
+          <p:cNvPr id="149" name="Rounded Rectangle 209"/>
           <p:cNvSpPr/>
           <p:nvPr/>
         </p:nvSpPr>
@@ -19554,7 +19609,7 @@
                 <a:latin typeface="Arial"/>
                 <a:ea typeface="Arial"/>
               </a:rPr>
-              <a:t>2. SUPERVISOR &amp; BDI</a:t>
+              <a:t>2. SUPERVISOR &amp; TAREFAS</a:t>
             </a:r>
             <a:endParaRPr lang="pt-BR" sz="1100" b="0" u="none" strike="noStrike">
               <a:solidFill>
@@ -19571,11 +19626,11 @@
                 <a:spcPct val="100000"/>
               </a:lnSpc>
               <a:spcBef>
-                <a:spcPts val="799"/>
-              </a:spcBef>
-            </a:pPr>
-            <a:r>
-              <a:rPr lang="pt-BR" sz="900" b="0" u="none" strike="noStrike">
+                <a:spcPts val="601"/>
+              </a:spcBef>
+            </a:pPr>
+            <a:r>
+              <a:rPr lang="pt-BR" sz="850" b="0" u="none" strike="noStrike">
                 <a:solidFill>
                   <a:srgbClr val="F1F5F9"/>
                 </a:solidFill>
@@ -19587,10 +19642,10 @@
               <a:t>• Orquestrador Central:</a:t>
             </a:r>
             <a:br>
-              <a:rPr sz="900"/>
+              <a:rPr sz="850"/>
             </a:br>
             <a:r>
-              <a:rPr lang="pt-BR" sz="900" b="0" u="none" strike="noStrike">
+              <a:rPr lang="pt-BR" sz="850" b="0" u="none" strike="noStrike">
                 <a:solidFill>
                   <a:srgbClr val="F1F5F9"/>
                 </a:solidFill>
@@ -19602,13 +19657,13 @@
               <a:t>  Topologia Hierárquica Supervisor.</a:t>
             </a:r>
             <a:br>
-              <a:rPr sz="900"/>
+              <a:rPr sz="850"/>
             </a:br>
             <a:br>
-              <a:rPr sz="900"/>
+              <a:rPr sz="850"/>
             </a:br>
             <a:r>
-              <a:rPr lang="pt-BR" sz="900" b="0" u="none" strike="noStrike">
+              <a:rPr lang="pt-BR" sz="850" b="0" u="none" strike="noStrike">
                 <a:solidFill>
                   <a:srgbClr val="F1F5F9"/>
                 </a:solidFill>
@@ -19620,10 +19675,10 @@
               <a:t>• Loop Cognitivo BDI:</a:t>
             </a:r>
             <a:br>
-              <a:rPr sz="900"/>
+              <a:rPr sz="850"/>
             </a:br>
             <a:r>
-              <a:rPr lang="pt-BR" sz="900" b="0" u="none" strike="noStrike">
+              <a:rPr lang="pt-BR" sz="850" b="0" u="none" strike="noStrike">
                 <a:solidFill>
                   <a:srgbClr val="F1F5F9"/>
                 </a:solidFill>
@@ -19635,10 +19690,10 @@
               <a:t>  - Beliefs: Histórico Olist &amp; RAG</a:t>
             </a:r>
             <a:br>
-              <a:rPr sz="900"/>
+              <a:rPr sz="850"/>
             </a:br>
             <a:r>
-              <a:rPr lang="pt-BR" sz="900" b="0" u="none" strike="noStrike">
+              <a:rPr lang="pt-BR" sz="850" b="0" u="none" strike="noStrike">
                 <a:solidFill>
                   <a:srgbClr val="F1F5F9"/>
                 </a:solidFill>
@@ -19647,13 +19702,13 @@
                 <a:latin typeface="Arial"/>
                 <a:ea typeface="Arial"/>
               </a:rPr>
-              <a:t>  - Desires: Metas de NPS e retenção</a:t>
+              <a:t>  - Desires: Metas de NPS e SLA</a:t>
             </a:r>
             <a:br>
-              <a:rPr sz="900"/>
+              <a:rPr sz="850"/>
             </a:br>
             <a:r>
-              <a:rPr lang="pt-BR" sz="900" b="0" u="none" strike="noStrike">
+              <a:rPr lang="pt-BR" sz="850" b="0" u="none" strike="noStrike">
                 <a:solidFill>
                   <a:srgbClr val="F1F5F9"/>
                 </a:solidFill>
@@ -19665,13 +19720,13 @@
               <a:t>  - Intentions: Tool calling estruturado</a:t>
             </a:r>
             <a:br>
-              <a:rPr sz="900"/>
+              <a:rPr sz="850"/>
             </a:br>
             <a:br>
-              <a:rPr sz="900"/>
+              <a:rPr sz="850"/>
             </a:br>
             <a:r>
-              <a:rPr lang="pt-BR" sz="900" b="0" u="none" strike="noStrike">
+              <a:rPr lang="pt-BR" sz="850" b="0" u="none" strike="noStrike">
                 <a:solidFill>
                   <a:srgbClr val="F1F5F9"/>
                 </a:solidFill>
@@ -19680,13 +19735,13 @@
                 <a:latin typeface="Arial"/>
                 <a:ea typeface="Arial"/>
               </a:rPr>
-              <a:t>• Shared State:</a:t>
+              <a:t>• Mapa de 6 Macroetapas:</a:t>
             </a:r>
             <a:br>
-              <a:rPr sz="900"/>
+              <a:rPr sz="850"/>
             </a:br>
             <a:r>
-              <a:rPr lang="pt-BR" sz="900" b="0" u="none" strike="noStrike">
+              <a:rPr lang="pt-BR" sz="850" b="0" u="none" strike="noStrike">
                 <a:solidFill>
                   <a:srgbClr val="F1F5F9"/>
                 </a:solidFill>
@@ -19695,9 +19750,39 @@
                 <a:latin typeface="Arial"/>
                 <a:ea typeface="Arial"/>
               </a:rPr>
-              <a:t>  Grafo de sessão e logs unificados.</a:t>
-            </a:r>
-            <a:endParaRPr lang="pt-BR" sz="900" b="0" u="none" strike="noStrike">
+              <a:t>  1. Trigger ➔ 2. Ingestão/Tools ➔</a:t>
+            </a:r>
+            <a:br>
+              <a:rPr sz="850"/>
+            </a:br>
+            <a:r>
+              <a:rPr lang="pt-BR" sz="850" b="0" u="none" strike="noStrike">
+                <a:solidFill>
+                  <a:srgbClr val="F1F5F9"/>
+                </a:solidFill>
+                <a:effectLst/>
+                <a:uFillTx/>
+                <a:latin typeface="Arial"/>
+                <a:ea typeface="Arial"/>
+              </a:rPr>
+              <a:t>  3. Raciocínio CoT ➔ 4. Guardrails ➔</a:t>
+            </a:r>
+            <a:br>
+              <a:rPr sz="850"/>
+            </a:br>
+            <a:r>
+              <a:rPr lang="pt-BR" sz="850" b="0" u="none" strike="noStrike">
+                <a:solidFill>
+                  <a:srgbClr val="F1F5F9"/>
+                </a:solidFill>
+                <a:effectLst/>
+                <a:uFillTx/>
+                <a:latin typeface="Arial"/>
+                <a:ea typeface="Arial"/>
+              </a:rPr>
+              <a:t>  5. Execução/HITL ➔ 6. Auditoria.</a:t>
+            </a:r>
+            <a:endParaRPr lang="pt-BR" sz="850" b="0" u="none" strike="noStrike">
               <a:solidFill>
                 <a:srgbClr val="FFFFFF"/>
               </a:solidFill>
@@ -19710,7 +19795,7 @@
       </p:sp>
       <p:sp>
         <p:nvSpPr>
-          <p:cNvPr id="149" name="Rounded Rectangle 210"/>
+          <p:cNvPr id="150" name="Rounded Rectangle 210"/>
           <p:cNvSpPr/>
           <p:nvPr/>
         </p:nvSpPr>
@@ -19962,7 +20047,7 @@
       </p:grpSpPr>
       <p:sp>
         <p:nvSpPr>
-          <p:cNvPr id="150" name="Google Shape;213;p28"/>
+          <p:cNvPr id="151" name="Google Shape;213;p28"/>
           <p:cNvSpPr/>
           <p:nvPr/>
         </p:nvSpPr>
@@ -20013,14 +20098,14 @@
       </p:sp>
       <p:sp>
         <p:nvSpPr>
-          <p:cNvPr id="151" name="Google Shape;214;p28"/>
+          <p:cNvPr id="152" name="Google Shape;214;p28"/>
           <p:cNvSpPr/>
           <p:nvPr/>
         </p:nvSpPr>
         <p:spPr>
           <a:xfrm>
-            <a:off x="548640" y="1174680"/>
-            <a:ext cx="7551360" cy="396720"/>
+            <a:off x="548640" y="923400"/>
+            <a:ext cx="8448840" cy="392760"/>
           </a:xfrm>
           <a:prstGeom prst="rect">
             <a:avLst/>
@@ -20059,7 +20144,7 @@
                 <a:latin typeface="Arial"/>
                 <a:ea typeface="Arial"/>
               </a:rPr>
-              <a:t>3. Human-Centered AI (HCAI) &amp; Storyboards das 3 Jornadas</a:t>
+              <a:t>3. Human-Centered AI (HCAI), Storyboards &amp; Prompts de Produção</a:t>
             </a:r>
             <a:endParaRPr lang="pt-BR" sz="2000" b="0" u="none" strike="noStrike">
               <a:solidFill>
@@ -20074,7 +20159,7 @@
       </p:sp>
       <p:sp>
         <p:nvSpPr>
-          <p:cNvPr id="152" name="Google Shape;219;p28"/>
+          <p:cNvPr id="153" name="Google Shape;219;p28"/>
           <p:cNvSpPr/>
           <p:nvPr/>
         </p:nvSpPr>
@@ -20125,7 +20210,7 @@
       </p:sp>
       <p:sp>
         <p:nvSpPr>
-          <p:cNvPr id="153" name="Google Shape;220;p28"/>
+          <p:cNvPr id="154" name="Google Shape;220;p28"/>
           <p:cNvSpPr/>
           <p:nvPr/>
         </p:nvSpPr>
@@ -20171,7 +20256,7 @@
                 <a:latin typeface="Arial"/>
                 <a:ea typeface="Arial"/>
               </a:rPr>
-              <a:t>Framework: Ben Shneiderman (Stanford HAI) | Copiloto Supervisionado nos Primeiros 90 Dias</a:t>
+              <a:t>Framework: Ben Shneiderman (HCAI) | Storyboards de 3 Jornadas | Contratos Estritos JSON Schema</a:t>
             </a:r>
             <a:endParaRPr lang="pt-BR" sz="850" b="0" u="none" strike="noStrike">
               <a:solidFill>
@@ -20186,7 +20271,7 @@
       </p:sp>
       <p:sp>
         <p:nvSpPr>
-          <p:cNvPr id="154" name="Google Shape;221;p28"/>
+          <p:cNvPr id="155" name="Google Shape;221;p28"/>
           <p:cNvSpPr/>
           <p:nvPr/>
         </p:nvSpPr>
@@ -20247,7 +20332,7 @@
       </p:sp>
       <p:sp>
         <p:nvSpPr>
-          <p:cNvPr id="155" name="PlaceHolder 1"/>
+          <p:cNvPr id="156" name="PlaceHolder 1"/>
           <p:cNvSpPr>
             <a:spLocks noGrp="1"/>
           </p:cNvSpPr>
@@ -20270,7 +20355,7 @@
         </p:spPr>
         <p:txBody>
           <a:bodyPr lIns="91440" tIns="45720" rIns="91440" bIns="45720" anchor="t">
-            <a:normAutofit fontScale="25000" lnSpcReduction="19999"/>
+            <a:normAutofit/>
           </a:bodyPr>
           <a:p>
             <a:pPr indent="0" algn="l">
@@ -20283,9 +20368,9 @@
               </a:tabLst>
             </a:pPr>
             <a:r>
-              <a:rPr lang="en-US" sz="7680" b="0" u="none" strike="noStrike">
-                <a:solidFill>
-                  <a:srgbClr val="C8C8C8"/>
+              <a:rPr lang="pt-BR" sz="1400" b="0" u="none" strike="noStrike">
+                <a:solidFill>
+                  <a:srgbClr val="94A3B8"/>
                 </a:solidFill>
                 <a:effectLst/>
                 <a:uFillTx/>
@@ -20294,7 +20379,7 @@
               </a:rPr>
               <a:t>Tech Challenge – Fase 2</a:t>
             </a:r>
-            <a:endParaRPr lang="pt-BR" sz="7680" b="0" u="none" strike="noStrike">
+            <a:endParaRPr lang="pt-BR" sz="1400" b="0" u="none" strike="noStrike">
               <a:solidFill>
                 <a:srgbClr val="000000"/>
               </a:solidFill>
@@ -20307,7 +20392,7 @@
       </p:sp>
       <p:pic>
         <p:nvPicPr>
-          <p:cNvPr id="156" name="Google Shape;223;p28"/>
+          <p:cNvPr id="157" name="Google Shape;223;p28"/>
           <p:cNvPicPr/>
           <p:nvPr/>
         </p:nvPicPr>
@@ -20331,7 +20416,7 @@
       </p:pic>
       <p:pic>
         <p:nvPicPr>
-          <p:cNvPr id="157" name="Google Shape;224;p28"/>
+          <p:cNvPr id="158" name="Google Shape;224;p28"/>
           <p:cNvPicPr/>
           <p:nvPr/>
         </p:nvPicPr>
@@ -20355,7 +20440,7 @@
       </p:pic>
       <p:sp>
         <p:nvSpPr>
-          <p:cNvPr id="158" name="Google Shape;225;p28"/>
+          <p:cNvPr id="159" name="Google Shape;225;p28"/>
           <p:cNvSpPr/>
           <p:nvPr/>
         </p:nvSpPr>
@@ -20392,18 +20477,18 @@
               </a:tabLst>
             </a:pPr>
             <a:r>
-              <a:rPr lang="en-US" sz="3200" b="0" u="none" strike="noStrike">
-                <a:solidFill>
-                  <a:srgbClr val="A3284D"/>
-                </a:solidFill>
-                <a:effectLst/>
-                <a:uFillTx/>
-                <a:latin typeface="Calibri"/>
-                <a:ea typeface="Calibri"/>
+              <a:rPr lang="pt-BR" sz="1800" b="1" u="none" strike="noStrike">
+                <a:solidFill>
+                  <a:srgbClr val="FFFFFF"/>
+                </a:solidFill>
+                <a:effectLst/>
+                <a:uFillTx/>
+                <a:latin typeface="Arial"/>
+                <a:ea typeface="Arial"/>
               </a:rPr>
               <a:t>Agentes de IA</a:t>
             </a:r>
-            <a:endParaRPr lang="pt-BR" sz="3200" b="0" u="none" strike="noStrike">
+            <a:endParaRPr lang="pt-BR" sz="1800" b="0" u="none" strike="noStrike">
               <a:solidFill>
                 <a:srgbClr val="000000"/>
               </a:solidFill>
@@ -20416,7 +20501,7 @@
       </p:sp>
       <p:pic>
         <p:nvPicPr>
-          <p:cNvPr id="159" name="Picture 225" descr="matriz_hcai_shneiderman.png"/>
+          <p:cNvPr id="160" name="Picture 225" descr="matriz_hcai_shneiderman.png"/>
           <p:cNvPicPr/>
           <p:nvPr/>
         </p:nvPicPr>
@@ -20426,8 +20511,8 @@
         </p:blipFill>
         <p:spPr>
           <a:xfrm>
-            <a:off x="548640" y="1920240"/>
-            <a:ext cx="4851360" cy="4068720"/>
+            <a:off x="548640" y="1783080"/>
+            <a:ext cx="4068720" cy="3840120"/>
           </a:xfrm>
           <a:prstGeom prst="rect">
             <a:avLst/>
@@ -20440,14 +20525,121 @@
       </p:pic>
       <p:sp>
         <p:nvSpPr>
-          <p:cNvPr id="160" name="Rounded Rectangle 226"/>
+          <p:cNvPr id="161" name="Rounded Rectangle 226">
+            <a:hlinkClick r:id="rId4"/>
+          </p:cNvPr>
           <p:cNvSpPr/>
           <p:nvPr/>
         </p:nvSpPr>
         <p:spPr>
           <a:xfrm>
-            <a:off x="5618880" y="1920240"/>
-            <a:ext cx="2985120" cy="4068720"/>
+            <a:off x="548640" y="5669280"/>
+            <a:ext cx="4068720" cy="383760"/>
+          </a:xfrm>
+          <a:prstGeom prst="roundRect">
+            <a:avLst>
+              <a:gd name="adj" fmla="val 16667"/>
+            </a:avLst>
+          </a:prstGeom>
+          <a:solidFill>
+            <a:srgbClr val="141B2D"/>
+          </a:solidFill>
+          <a:ln>
+            <a:solidFill>
+              <a:srgbClr val="334155"/>
+            </a:solidFill>
+            <a:round/>
+          </a:ln>
+          <a:effectLst>
+            <a:outerShdw blurRad="39960" dir="5400000" dist="23040" rotWithShape="0">
+              <a:srgbClr val="000000">
+                <a:alpha val="35000"/>
+              </a:srgbClr>
+            </a:outerShdw>
+          </a:effectLst>
+        </p:spPr>
+        <p:style>
+          <a:lnRef idx="1">
+            <a:schemeClr val="accent1"/>
+          </a:lnRef>
+          <a:fillRef idx="3">
+            <a:schemeClr val="accent1"/>
+          </a:fillRef>
+          <a:effectRef idx="2">
+            <a:schemeClr val="accent1"/>
+          </a:effectRef>
+          <a:fontRef idx="minor"/>
+        </p:style>
+        <p:txBody>
+          <a:bodyPr lIns="73080" tIns="36720" rIns="73080" bIns="36720" anchor="ctr">
+            <a:noAutofit/>
+          </a:bodyPr>
+          <a:p>
+            <a:pPr>
+              <a:lnSpc>
+                <a:spcPct val="100000"/>
+              </a:lnSpc>
+            </a:pPr>
+            <a:r>
+              <a:rPr lang="pt-BR" sz="750" b="1" u="none" strike="noStrike">
+                <a:solidFill>
+                  <a:srgbClr val="EA1D5D"/>
+                </a:solidFill>
+                <a:effectLst/>
+                <a:uFillTx/>
+                <a:latin typeface="Arial"/>
+                <a:ea typeface="Arial"/>
+              </a:rPr>
+              <a:t>🔗 Repositório GitHub (master) — matriz_hcai_shneiderman.png</a:t>
+            </a:r>
+            <a:endParaRPr lang="pt-BR" sz="750" b="0" u="none" strike="noStrike">
+              <a:solidFill>
+                <a:srgbClr val="FFFFFF"/>
+              </a:solidFill>
+              <a:effectLst/>
+              <a:uFillTx/>
+              <a:latin typeface="Arial"/>
+            </a:endParaRPr>
+          </a:p>
+          <a:p>
+            <a:pPr>
+              <a:lnSpc>
+                <a:spcPct val="100000"/>
+              </a:lnSpc>
+            </a:pPr>
+            <a:r>
+              <a:rPr lang="pt-BR" sz="620" b="0" u="sng" strike="noStrike">
+                <a:solidFill>
+                  <a:srgbClr val="EA1D5D"/>
+                </a:solidFill>
+                <a:effectLst/>
+                <a:uFillTx/>
+                <a:latin typeface="Arial"/>
+                <a:ea typeface="Arial"/>
+              </a:rPr>
+              <a:t>https://github.com/professoralessandro/FIAP-POS-TECH-AGENTESIA/blob/master/Tech%20Challenge%20Fase%202/assets/matriz_hcai_shneiderman.png</a:t>
+            </a:r>
+            <a:endParaRPr lang="pt-BR" sz="620" b="0" u="none" strike="noStrike">
+              <a:solidFill>
+                <a:srgbClr val="FFFFFF"/>
+              </a:solidFill>
+              <a:effectLst/>
+              <a:uFillTx/>
+              <a:latin typeface="Arial"/>
+            </a:endParaRPr>
+          </a:p>
+        </p:txBody>
+      </p:sp>
+      <p:sp>
+        <p:nvSpPr>
+          <p:cNvPr id="162" name="Rounded Rectangle 227"/>
+          <p:cNvSpPr/>
+          <p:nvPr/>
+        </p:nvSpPr>
+        <p:spPr>
+          <a:xfrm>
+            <a:off x="4754880" y="1783080"/>
+            <a:ext cx="3840120" cy="4269960"/>
           </a:xfrm>
           <a:prstGeom prst="roundRect">
             <a:avLst>
@@ -20524,7 +20716,7 @@
               </a:spcBef>
             </a:pPr>
             <a:r>
-              <a:rPr lang="pt-BR" sz="880" b="0" u="none" strike="noStrike">
+              <a:rPr lang="pt-BR" sz="850" b="0" u="none" strike="noStrike">
                 <a:solidFill>
                   <a:srgbClr val="94A3B8"/>
                 </a:solidFill>
@@ -20535,7 +20727,7 @@
               </a:rPr>
               <a:t>Rejeita 'caixas pretas' sem supervisão. Agentes operam como Copilotos com Human-in-the-Loop (HITL) nos primeiros 90 dias.</a:t>
             </a:r>
-            <a:endParaRPr lang="pt-BR" sz="880" b="0" u="none" strike="noStrike">
+            <a:endParaRPr lang="pt-BR" sz="850" b="0" u="none" strike="noStrike">
               <a:solidFill>
                 <a:srgbClr val="FFFFFF"/>
               </a:solidFill>
@@ -20550,11 +20742,11 @@
                 <a:spcPct val="100000"/>
               </a:lnSpc>
               <a:spcBef>
-                <a:spcPts val="601"/>
-              </a:spcBef>
-            </a:pPr>
-            <a:r>
-              <a:rPr lang="pt-BR" sz="1050" b="1" u="none" strike="noStrike">
+                <a:spcPts val="499"/>
+              </a:spcBef>
+            </a:pPr>
+            <a:r>
+              <a:rPr lang="pt-BR" sz="1000" b="1" u="none" strike="noStrike">
                 <a:solidFill>
                   <a:srgbClr val="38BDF8"/>
                 </a:solidFill>
@@ -20563,9 +20755,9 @@
                 <a:latin typeface="Arial"/>
                 <a:ea typeface="Arial"/>
               </a:rPr>
-              <a:t>AS 3 JORNADAS OPERACIONAIS</a:t>
-            </a:r>
-            <a:endParaRPr lang="pt-BR" sz="1050" b="0" u="none" strike="noStrike">
+              <a:t>AS 3 JORNADAS OPERACIONAIS (MAPA DE TAREFAS)</a:t>
+            </a:r>
+            <a:endParaRPr lang="pt-BR" sz="1000" b="0" u="none" strike="noStrike">
               <a:solidFill>
                 <a:srgbClr val="FFFFFF"/>
               </a:solidFill>
@@ -20580,11 +20772,11 @@
                 <a:spcPct val="100000"/>
               </a:lnSpc>
               <a:spcBef>
-                <a:spcPts val="300"/>
-              </a:spcBef>
-            </a:pPr>
-            <a:r>
-              <a:rPr lang="pt-BR" sz="850" b="0" u="none" strike="noStrike">
+                <a:spcPts val="201"/>
+              </a:spcBef>
+            </a:pPr>
+            <a:r>
+              <a:rPr lang="pt-BR" sz="820" b="0" u="none" strike="noStrike">
                 <a:solidFill>
                   <a:srgbClr val="F1F5F9"/>
                 </a:solidFill>
@@ -20593,13 +20785,13 @@
                 <a:latin typeface="Arial"/>
                 <a:ea typeface="Arial"/>
               </a:rPr>
-              <a:t>[J1] Resolução de Atrasos (CX):</a:t>
+              <a:t>• [J1] Resolução CX: Rascunho pronto com validação 1-clique.</a:t>
             </a:r>
             <a:br>
-              <a:rPr sz="850"/>
+              <a:rPr sz="820"/>
             </a:br>
             <a:r>
-              <a:rPr lang="pt-BR" sz="850" b="0" u="none" strike="noStrike">
+              <a:rPr lang="pt-BR" sz="820" b="0" u="none" strike="noStrike">
                 <a:solidFill>
                   <a:srgbClr val="F1F5F9"/>
                 </a:solidFill>
@@ -20608,13 +20800,13 @@
                 <a:latin typeface="Arial"/>
                 <a:ea typeface="Arial"/>
               </a:rPr>
-              <a:t>- Rascunho empático pronto em segundos</a:t>
+              <a:t>• [J2] Auditoria Frete: Isola seller de falhas dos Correios.</a:t>
             </a:r>
             <a:br>
-              <a:rPr sz="850"/>
+              <a:rPr sz="820"/>
             </a:br>
             <a:r>
-              <a:rPr lang="pt-BR" sz="850" b="0" u="none" strike="noStrike">
+              <a:rPr lang="pt-BR" sz="820" b="0" u="none" strike="noStrike">
                 <a:solidFill>
                   <a:srgbClr val="F1F5F9"/>
                 </a:solidFill>
@@ -20623,135 +20815,99 @@
                 <a:latin typeface="Arial"/>
                 <a:ea typeface="Arial"/>
               </a:rPr>
-              <a:t>- Aprovação pelo analista de SAC em 1 clique</a:t>
+              <a:t>• [J3] Reativação Churn: Cupons dentro da margem (&lt; 10%).</a:t>
+            </a:r>
+            <a:endParaRPr lang="pt-BR" sz="820" b="0" u="none" strike="noStrike">
+              <a:solidFill>
+                <a:srgbClr val="FFFFFF"/>
+              </a:solidFill>
+              <a:effectLst/>
+              <a:uFillTx/>
+              <a:latin typeface="Arial"/>
+            </a:endParaRPr>
+          </a:p>
+          <a:p>
+            <a:pPr>
+              <a:lnSpc>
+                <a:spcPct val="100000"/>
+              </a:lnSpc>
+              <a:spcBef>
+                <a:spcPts val="601"/>
+              </a:spcBef>
+            </a:pPr>
+            <a:r>
+              <a:rPr lang="pt-BR" sz="1000" b="1" u="none" strike="noStrike">
+                <a:solidFill>
+                  <a:srgbClr val="FBBF24"/>
+                </a:solidFill>
+                <a:effectLst/>
+                <a:uFillTx/>
+                <a:latin typeface="Arial"/>
+                <a:ea typeface="Arial"/>
+              </a:rPr>
+              <a:t>ENGENHARIA DE PROMPTS DE PRODUÇÃO</a:t>
+            </a:r>
+            <a:endParaRPr lang="pt-BR" sz="1000" b="0" u="none" strike="noStrike">
+              <a:solidFill>
+                <a:srgbClr val="FFFFFF"/>
+              </a:solidFill>
+              <a:effectLst/>
+              <a:uFillTx/>
+              <a:latin typeface="Arial"/>
+            </a:endParaRPr>
+          </a:p>
+          <a:p>
+            <a:pPr>
+              <a:lnSpc>
+                <a:spcPct val="100000"/>
+              </a:lnSpc>
+              <a:spcBef>
+                <a:spcPts val="201"/>
+              </a:spcBef>
+            </a:pPr>
+            <a:r>
+              <a:rPr lang="pt-BR" sz="820" b="0" u="none" strike="noStrike">
+                <a:solidFill>
+                  <a:srgbClr val="FFFFFF"/>
+                </a:solidFill>
+                <a:effectLst/>
+                <a:uFillTx/>
+                <a:latin typeface="Arial"/>
+                <a:ea typeface="Arial"/>
+              </a:rPr>
+              <a:t>• System Prompts com Chain-of-Thought e Guardrails Éticos</a:t>
             </a:r>
             <a:br>
-              <a:rPr sz="850"/>
+              <a:rPr sz="820"/>
             </a:br>
             <a:r>
-              <a:rPr lang="pt-BR" sz="850" b="0" u="none" strike="noStrike">
-                <a:solidFill>
-                  <a:srgbClr val="F1F5F9"/>
+              <a:rPr lang="pt-BR" sz="820" b="0" u="none" strike="noStrike">
+                <a:solidFill>
+                  <a:srgbClr val="FFFFFF"/>
                 </a:solidFill>
                 <a:effectLst/>
                 <a:uFillTx/>
                 <a:latin typeface="Arial"/>
                 <a:ea typeface="Arial"/>
               </a:rPr>
-              <a:t>- Redução da perda de NPS em até 25%</a:t>
+              <a:t>• Few-Shot com dados autênticos do dataset Olist</a:t>
             </a:r>
             <a:br>
-              <a:rPr sz="850"/>
+              <a:rPr sz="820"/>
             </a:br>
-            <a:br>
-              <a:rPr sz="850"/>
-            </a:br>
-            <a:r>
-              <a:rPr lang="pt-BR" sz="850" b="0" u="none" strike="noStrike">
-                <a:solidFill>
-                  <a:srgbClr val="F1F5F9"/>
+            <a:r>
+              <a:rPr lang="pt-BR" sz="820" b="0" u="none" strike="noStrike">
+                <a:solidFill>
+                  <a:srgbClr val="FFFFFF"/>
                 </a:solidFill>
                 <a:effectLst/>
                 <a:uFillTx/>
                 <a:latin typeface="Arial"/>
                 <a:ea typeface="Arial"/>
               </a:rPr>
-              <a:t>[J2] Diagnóstico de Frete (Logística):</a:t>
-            </a:r>
-            <a:br>
-              <a:rPr sz="850"/>
-            </a:br>
-            <a:r>
-              <a:rPr lang="pt-BR" sz="850" b="0" u="none" strike="noStrike">
-                <a:solidFill>
-                  <a:srgbClr val="F1F5F9"/>
-                </a:solidFill>
-                <a:effectLst/>
-                <a:uFillTx/>
-                <a:latin typeface="Arial"/>
-                <a:ea typeface="Arial"/>
-              </a:rPr>
-              <a:t>- Auditoria causal justa: Seller vs. Correios</a:t>
-            </a:r>
-            <a:br>
-              <a:rPr sz="850"/>
-            </a:br>
-            <a:r>
-              <a:rPr lang="pt-BR" sz="850" b="0" u="none" strike="noStrike">
-                <a:solidFill>
-                  <a:srgbClr val="F1F5F9"/>
-                </a:solidFill>
-                <a:effectLst/>
-                <a:uFillTx/>
-                <a:latin typeface="Arial"/>
-                <a:ea typeface="Arial"/>
-              </a:rPr>
-              <a:t>- Proteção da reputação de sellers pontuais</a:t>
-            </a:r>
-            <a:br>
-              <a:rPr sz="850"/>
-            </a:br>
-            <a:r>
-              <a:rPr lang="pt-BR" sz="850" b="0" u="none" strike="noStrike">
-                <a:solidFill>
-                  <a:srgbClr val="F1F5F9"/>
-                </a:solidFill>
-                <a:effectLst/>
-                <a:uFillTx/>
-                <a:latin typeface="Arial"/>
-                <a:ea typeface="Arial"/>
-              </a:rPr>
-              <a:t>- Alerta preventivo antes da reclamação</a:t>
-            </a:r>
-            <a:br>
-              <a:rPr sz="850"/>
-            </a:br>
-            <a:br>
-              <a:rPr sz="850"/>
-            </a:br>
-            <a:r>
-              <a:rPr lang="pt-BR" sz="850" b="0" u="none" strike="noStrike">
-                <a:solidFill>
-                  <a:srgbClr val="F1F5F9"/>
-                </a:solidFill>
-                <a:effectLst/>
-                <a:uFillTx/>
-                <a:latin typeface="Arial"/>
-                <a:ea typeface="Arial"/>
-              </a:rPr>
-              <a:t>[J3] Reativação de Churn (Sellers):</a:t>
-            </a:r>
-            <a:br>
-              <a:rPr sz="850"/>
-            </a:br>
-            <a:r>
-              <a:rPr lang="pt-BR" sz="850" b="0" u="none" strike="noStrike">
-                <a:solidFill>
-                  <a:srgbClr val="F1F5F9"/>
-                </a:solidFill>
-                <a:effectLst/>
-                <a:uFillTx/>
-                <a:latin typeface="Arial"/>
-                <a:ea typeface="Arial"/>
-              </a:rPr>
-              <a:t>- Análise RFM da base hibernada (R$ 4,57M)</a:t>
-            </a:r>
-            <a:br>
-              <a:rPr sz="850"/>
-            </a:br>
-            <a:r>
-              <a:rPr lang="pt-BR" sz="850" b="0" u="none" strike="noStrike">
-                <a:solidFill>
-                  <a:srgbClr val="F1F5F9"/>
-                </a:solidFill>
-                <a:effectLst/>
-                <a:uFillTx/>
-                <a:latin typeface="Arial"/>
-                <a:ea typeface="Arial"/>
-              </a:rPr>
-              <a:t>- Recomendações afins com teto de cupom (10%)</a:t>
-            </a:r>
-            <a:endParaRPr lang="pt-BR" sz="850" b="0" u="none" strike="noStrike">
+              <a:t>• Contratos estritos de saída em JSON Schema formal</a:t>
+            </a:r>
+            <a:endParaRPr lang="pt-BR" sz="820" b="0" u="none" strike="noStrike">
               <a:solidFill>
                 <a:srgbClr val="FFFFFF"/>
               </a:solidFill>
@@ -20794,14 +20950,14 @@
       </p:grpSpPr>
       <p:sp>
         <p:nvSpPr>
-          <p:cNvPr id="161" name="Google Shape;230;p29"/>
+          <p:cNvPr id="163" name="Google Shape;230;p29"/>
           <p:cNvSpPr/>
           <p:nvPr/>
         </p:nvSpPr>
         <p:spPr>
           <a:xfrm>
-            <a:off x="0" y="0"/>
-            <a:ext cx="9143640" cy="6857640"/>
+            <a:off x="0" y="-11160"/>
+            <a:ext cx="9199080" cy="6857640"/>
           </a:xfrm>
           <a:prstGeom prst="rect">
             <a:avLst/>
@@ -20845,14 +21001,14 @@
       </p:sp>
       <p:sp>
         <p:nvSpPr>
-          <p:cNvPr id="162" name="Google Shape;231;p29"/>
+          <p:cNvPr id="164" name="Google Shape;231;p29"/>
           <p:cNvSpPr/>
           <p:nvPr/>
         </p:nvSpPr>
         <p:spPr>
           <a:xfrm>
-            <a:off x="548640" y="1184400"/>
-            <a:ext cx="8091360" cy="396720"/>
+            <a:off x="548640" y="932760"/>
+            <a:ext cx="8092080" cy="392760"/>
           </a:xfrm>
           <a:prstGeom prst="rect">
             <a:avLst/>
@@ -20906,7 +21062,7 @@
       </p:sp>
       <p:sp>
         <p:nvSpPr>
-          <p:cNvPr id="163" name="Google Shape;236;p29"/>
+          <p:cNvPr id="165" name="Google Shape;236;p29"/>
           <p:cNvSpPr/>
           <p:nvPr/>
         </p:nvSpPr>
@@ -20957,7 +21113,7 @@
       </p:sp>
       <p:sp>
         <p:nvSpPr>
-          <p:cNvPr id="164" name="Google Shape;237;p29"/>
+          <p:cNvPr id="166" name="Google Shape;237;p29"/>
           <p:cNvSpPr/>
           <p:nvPr/>
         </p:nvSpPr>
@@ -21018,7 +21174,7 @@
       </p:sp>
       <p:sp>
         <p:nvSpPr>
-          <p:cNvPr id="165" name="Google Shape;238;p29"/>
+          <p:cNvPr id="167" name="Google Shape;238;p29"/>
           <p:cNvSpPr/>
           <p:nvPr/>
         </p:nvSpPr>
@@ -21079,7 +21235,7 @@
       </p:sp>
       <p:sp>
         <p:nvSpPr>
-          <p:cNvPr id="166" name="PlaceHolder 1"/>
+          <p:cNvPr id="168" name="PlaceHolder 1"/>
           <p:cNvSpPr>
             <a:spLocks noGrp="1"/>
           </p:cNvSpPr>
@@ -21102,7 +21258,7 @@
         </p:spPr>
         <p:txBody>
           <a:bodyPr lIns="91440" tIns="45720" rIns="91440" bIns="45720" anchor="t">
-            <a:normAutofit fontScale="25000" lnSpcReduction="19999"/>
+            <a:normAutofit/>
           </a:bodyPr>
           <a:p>
             <a:pPr indent="0" algn="l">
@@ -21115,9 +21271,9 @@
               </a:tabLst>
             </a:pPr>
             <a:r>
-              <a:rPr lang="en-US" sz="7680" b="0" u="none" strike="noStrike">
-                <a:solidFill>
-                  <a:srgbClr val="C8C8C8"/>
+              <a:rPr lang="pt-BR" sz="1400" b="0" u="none" strike="noStrike">
+                <a:solidFill>
+                  <a:srgbClr val="94A3B8"/>
                 </a:solidFill>
                 <a:effectLst/>
                 <a:uFillTx/>
@@ -21126,7 +21282,7 @@
               </a:rPr>
               <a:t>Tech Challenge – Fase 2</a:t>
             </a:r>
-            <a:endParaRPr lang="pt-BR" sz="7680" b="0" u="none" strike="noStrike">
+            <a:endParaRPr lang="pt-BR" sz="1400" b="0" u="none" strike="noStrike">
               <a:solidFill>
                 <a:srgbClr val="000000"/>
               </a:solidFill>
@@ -21139,7 +21295,7 @@
       </p:sp>
       <p:pic>
         <p:nvPicPr>
-          <p:cNvPr id="167" name="Google Shape;240;p29"/>
+          <p:cNvPr id="169" name="Google Shape;240;p29"/>
           <p:cNvPicPr/>
           <p:nvPr/>
         </p:nvPicPr>
@@ -21163,7 +21319,7 @@
       </p:pic>
       <p:pic>
         <p:nvPicPr>
-          <p:cNvPr id="168" name="Google Shape;241;p29"/>
+          <p:cNvPr id="170" name="Google Shape;241;p29"/>
           <p:cNvPicPr/>
           <p:nvPr/>
         </p:nvPicPr>
@@ -21187,7 +21343,7 @@
       </p:pic>
       <p:sp>
         <p:nvSpPr>
-          <p:cNvPr id="169" name="Google Shape;242;p29"/>
+          <p:cNvPr id="171" name="Google Shape;242;p29"/>
           <p:cNvSpPr/>
           <p:nvPr/>
         </p:nvSpPr>
@@ -21224,18 +21380,18 @@
               </a:tabLst>
             </a:pPr>
             <a:r>
-              <a:rPr lang="en-US" sz="3200" b="0" u="none" strike="noStrike">
-                <a:solidFill>
-                  <a:srgbClr val="A3284D"/>
-                </a:solidFill>
-                <a:effectLst/>
-                <a:uFillTx/>
-                <a:latin typeface="Calibri"/>
-                <a:ea typeface="Calibri"/>
+              <a:rPr lang="pt-BR" sz="1800" b="1" u="none" strike="noStrike">
+                <a:solidFill>
+                  <a:srgbClr val="FFFFFF"/>
+                </a:solidFill>
+                <a:effectLst/>
+                <a:uFillTx/>
+                <a:latin typeface="Arial"/>
+                <a:ea typeface="Arial"/>
               </a:rPr>
               <a:t>Agentes de IA</a:t>
             </a:r>
-            <a:endParaRPr lang="pt-BR" sz="3200" b="0" u="none" strike="noStrike">
+            <a:endParaRPr lang="pt-BR" sz="1800" b="0" u="none" strike="noStrike">
               <a:solidFill>
                 <a:srgbClr val="000000"/>
               </a:solidFill>
@@ -21248,7 +21404,7 @@
       </p:sp>
       <p:pic>
         <p:nvPicPr>
-          <p:cNvPr id="170" name="Picture 242" descr="curva_tco_12meses.png"/>
+          <p:cNvPr id="172" name="Picture 242" descr="curva_tco_12meses.png"/>
           <p:cNvPicPr/>
           <p:nvPr/>
         </p:nvPicPr>
@@ -21258,8 +21414,8 @@
         </p:blipFill>
         <p:spPr>
           <a:xfrm>
-            <a:off x="548640" y="1920240"/>
-            <a:ext cx="5031360" cy="4068720"/>
+            <a:off x="548640" y="1783080"/>
+            <a:ext cx="4160160" cy="3840120"/>
           </a:xfrm>
           <a:prstGeom prst="rect">
             <a:avLst/>
@@ -21272,14 +21428,121 @@
       </p:pic>
       <p:sp>
         <p:nvSpPr>
-          <p:cNvPr id="171" name="Rounded Rectangle 243"/>
+          <p:cNvPr id="173" name="Rounded Rectangle 243">
+            <a:hlinkClick r:id="rId4"/>
+          </p:cNvPr>
           <p:cNvSpPr/>
           <p:nvPr/>
         </p:nvSpPr>
         <p:spPr>
           <a:xfrm>
-            <a:off x="5638320" y="1920240"/>
-            <a:ext cx="2893680" cy="4068720"/>
+            <a:off x="548640" y="5669280"/>
+            <a:ext cx="4160160" cy="383760"/>
+          </a:xfrm>
+          <a:prstGeom prst="roundRect">
+            <a:avLst>
+              <a:gd name="adj" fmla="val 16667"/>
+            </a:avLst>
+          </a:prstGeom>
+          <a:solidFill>
+            <a:srgbClr val="141B2D"/>
+          </a:solidFill>
+          <a:ln>
+            <a:solidFill>
+              <a:srgbClr val="334155"/>
+            </a:solidFill>
+            <a:round/>
+          </a:ln>
+          <a:effectLst>
+            <a:outerShdw blurRad="39960" dir="5400000" dist="23040" rotWithShape="0">
+              <a:srgbClr val="000000">
+                <a:alpha val="35000"/>
+              </a:srgbClr>
+            </a:outerShdw>
+          </a:effectLst>
+        </p:spPr>
+        <p:style>
+          <a:lnRef idx="1">
+            <a:schemeClr val="accent1"/>
+          </a:lnRef>
+          <a:fillRef idx="3">
+            <a:schemeClr val="accent1"/>
+          </a:fillRef>
+          <a:effectRef idx="2">
+            <a:schemeClr val="accent1"/>
+          </a:effectRef>
+          <a:fontRef idx="minor"/>
+        </p:style>
+        <p:txBody>
+          <a:bodyPr lIns="73080" tIns="36720" rIns="73080" bIns="36720" anchor="ctr">
+            <a:noAutofit/>
+          </a:bodyPr>
+          <a:p>
+            <a:pPr>
+              <a:lnSpc>
+                <a:spcPct val="100000"/>
+              </a:lnSpc>
+            </a:pPr>
+            <a:r>
+              <a:rPr lang="pt-BR" sz="750" b="1" u="none" strike="noStrike">
+                <a:solidFill>
+                  <a:srgbClr val="EA1D5D"/>
+                </a:solidFill>
+                <a:effectLst/>
+                <a:uFillTx/>
+                <a:latin typeface="Arial"/>
+                <a:ea typeface="Arial"/>
+              </a:rPr>
+              <a:t>🔗 Repositório GitHub (master) — curva_tco_12meses.png</a:t>
+            </a:r>
+            <a:endParaRPr lang="pt-BR" sz="750" b="0" u="none" strike="noStrike">
+              <a:solidFill>
+                <a:srgbClr val="FFFFFF"/>
+              </a:solidFill>
+              <a:effectLst/>
+              <a:uFillTx/>
+              <a:latin typeface="Arial"/>
+            </a:endParaRPr>
+          </a:p>
+          <a:p>
+            <a:pPr>
+              <a:lnSpc>
+                <a:spcPct val="100000"/>
+              </a:lnSpc>
+            </a:pPr>
+            <a:r>
+              <a:rPr lang="pt-BR" sz="620" b="0" u="sng" strike="noStrike">
+                <a:solidFill>
+                  <a:srgbClr val="EA1D5D"/>
+                </a:solidFill>
+                <a:effectLst/>
+                <a:uFillTx/>
+                <a:latin typeface="Arial"/>
+                <a:ea typeface="Arial"/>
+              </a:rPr>
+              <a:t>https://github.com/professoralessandro/FIAP-POS-TECH-AGENTESIA/blob/master/Tech%20Challenge%20Fase%202/assets/curva_tco_12meses.png</a:t>
+            </a:r>
+            <a:endParaRPr lang="pt-BR" sz="620" b="0" u="none" strike="noStrike">
+              <a:solidFill>
+                <a:srgbClr val="FFFFFF"/>
+              </a:solidFill>
+              <a:effectLst/>
+              <a:uFillTx/>
+              <a:latin typeface="Arial"/>
+            </a:endParaRPr>
+          </a:p>
+        </p:txBody>
+      </p:sp>
+      <p:sp>
+        <p:nvSpPr>
+          <p:cNvPr id="174" name="Rounded Rectangle 244"/>
+          <p:cNvSpPr/>
+          <p:nvPr/>
+        </p:nvSpPr>
+        <p:spPr>
+          <a:xfrm>
+            <a:off x="4846320" y="1783080"/>
+            <a:ext cx="3748680" cy="4269960"/>
           </a:xfrm>
           <a:prstGeom prst="roundRect">
             <a:avLst>

</xml_diff>